<commit_message>
TSM Q3 2026 update: USD only throughout, Chart 2 window from 2010
Co-Authored-By: Claude Opus 5.5 <noreply@anthropic.com>
Claude-Session: https://claude.ai/code/session_01CcAoCWueyTsnD2ruKqRw87
</commit_message>
<xml_diff>
--- a/reports/TSM_Q3_2026/Earnings_Update_TSM_Q32026.pptx
+++ b/reports/TSM_Q3_2026/Earnings_Update_TSM_Q32026.pptx
@@ -1519,7 +1519,7 @@
                 <a:ea typeface="Nunito" pitchFamily="34" charset="-122"/>
                 <a:cs typeface="Nunito" pitchFamily="34" charset="-120"/>
               </a:rPr>
-              <a:t>Revenue of USD 46.7bn (+41% year on year) and EPS TWD 29.43 both beat consensus by about 3%.</a:t>
+              <a:t>Revenue of USD 46.7bn (+41%) and EPS of USD 4.54 per ADR both beat consensus by about 3%.</a:t>
             </a:r>
             <a:endParaRPr lang="en-US" sz="870" dirty="0"/>
           </a:p>
@@ -1762,7 +1762,7 @@
                 <a:ea typeface="Nunito" pitchFamily="34" charset="-122"/>
                 <a:cs typeface="Nunito" pitchFamily="34" charset="-120"/>
               </a:rPr>
-              <a:t>19.7x forward earnings: 16% above the 2005 to 2026 average, well below the one-year average of 23.3x.</a:t>
+              <a:t>19.7x forward earnings: 16% above the 2010 to 2026 average, well below the one-year average of 23.3x.</a:t>
             </a:r>
             <a:endParaRPr lang="en-US" sz="870" dirty="0"/>
           </a:p>
@@ -1966,7 +1966,7 @@
                 <a:ea typeface="Nunito" pitchFamily="34" charset="-122"/>
                 <a:cs typeface="Nunito" pitchFamily="34" charset="-120"/>
               </a:rPr>
-              <a:t>Q3 EPS</a:t>
+              <a:t>Q3 EPS per ADR</a:t>
             </a:r>
             <a:endParaRPr lang="en-US" sz="720" dirty="0"/>
           </a:p>
@@ -2005,7 +2005,7 @@
                 <a:ea typeface="Nunito" pitchFamily="34" charset="-122"/>
                 <a:cs typeface="Nunito" pitchFamily="34" charset="-120"/>
               </a:rPr>
-              <a:t>TWD 29.43</a:t>
+              <a:t>USD 4.54</a:t>
             </a:r>
             <a:endParaRPr lang="en-US" sz="1300" dirty="0"/>
           </a:p>
@@ -2500,7 +2500,7 @@
                 <a:ea typeface="Nunito" pitchFamily="34" charset="-122"/>
                 <a:cs typeface="Nunito" pitchFamily="34" charset="-120"/>
               </a:rPr>
-              <a:t>Surprise vs. pre-results consensus in %, gross margin in percentage points · Q4 guide at its USD 53.3bn midpoint vs. prior consensus · Revenue and margin consensus approximate</a:t>
+              <a:t>Surprise vs. pre-results consensus in %, gross margin in percentage points · Q4 guide at its USD 53.3bn midpoint vs. prior consensus · EPS per ADR in USD at the 15 October exchange rate · Revenue and margin consensus approximate</a:t>
             </a:r>
             <a:endParaRPr lang="en-US" sz="720" dirty="0"/>
           </a:p>
@@ -2647,7 +2647,7 @@
                 <a:ea typeface="Nunito" pitchFamily="34" charset="-122"/>
                 <a:cs typeface="Nunito" pitchFamily="34" charset="-120"/>
               </a:rPr>
-              <a:t>We stay positive on TSMC and would add on weakness around the results. We underwrite US dollar revenue growth of 44% in 2026 and an AI business compounding at more than 50% a year; consensus 12-month forward EPS is already up 99% over the past year. The debate has moved from demand to returns: capital spending of USD 60–64bn this year rises sharply in 2027 to 2028, and overseas fabs dilute gross margin by 3–4 points, which analysts expect pricing to cut to about 1 point. Tactically, the American depositary receipt (ADR) sits 13% below its 2 October record. The next test is the fourth-quarter release in mid-January 2027.</a:t>
+              <a:t>We stay positive on TSMC and would add on weakness around the results. We underwrite US dollar revenue growth of 44% in 2026 and an AI business compounding at more than 50% a year; consensus 12-month forward EPS is already up 88% in a year. The debate has moved from demand to returns: capital spending of USD 60–64bn this year rises sharply in 2027 to 2028, and overseas fabs dilute gross margin by 3–4 points, which analysts expect pricing to cut to about 1 point. Tactically, the American depositary receipt (ADR) sits 13% below its 2 October record. The next test is the fourth-quarter release in mid-January 2027.</a:t>
             </a:r>
             <a:endParaRPr lang="en-US" sz="870" dirty="0"/>
           </a:p>
@@ -2832,7 +2832,7 @@
                 <a:ea typeface="Nunito" pitchFamily="34" charset="-122"/>
                 <a:cs typeface="Nunito" pitchFamily="34" charset="-120"/>
               </a:rPr>
-              <a:t>Gross margin below 65%, the bottom of the fourth-quarter guide, and staying there through the 2nm and A14 ramps; capital spending above USD 100bn in 2027 without matching revenue; higher US tariffs on chips; an AI derating that takes the multiple below its 17.0x average.</a:t>
+              <a:t>Gross margin below 65%, the bottom of the fourth-quarter guide, and staying there through the 2nm and A14 ramps; capital spending above USD 100bn in 2027 without matching revenue; higher US tariffs on chips; an AI derating that takes the multiple below its 16.9x average.</a:t>
             </a:r>
             <a:endParaRPr lang="en-US" sz="870" dirty="0"/>
           </a:p>
@@ -3110,7 +3110,7 @@
                 <a:ea typeface="Nunito" pitchFamily="34" charset="-122"/>
                 <a:cs typeface="Nunito" pitchFamily="34" charset="-120"/>
               </a:rPr>
-              <a:t>Third-quarter revenue of USD 46.7bn rose 16.2% quarter on quarter, above guidance, and 41% year on year, about 3% ahead of consensus. High-performance computing (HPC), smartphones and automotive led demand, and the strength was broad rather than a single product cycle. Operating leverage was strong: the operating margin reached 58.7%, ahead of expectations, and EPS of TWD 29.43 beat the TWD 28.67 consensus by 2.7% and rose 69% year on year, in line with net income. This is the third consecutive quarter of beat-and-raise, and it came with an upgrade to the multi-year AI outlook, with agentic AI named as an additional growth engine on top of the cloud AI build-out.</a:t>
+              <a:t>Third-quarter revenue of USD 46.7bn rose 16.2% quarter on quarter, above guidance, and 41% year on year, about 3% ahead of consensus. High-performance computing (HPC), smartphones and automotive led demand, and the strength was broad rather than a single product cycle. Operating leverage was strong: the operating margin reached 58.7%, ahead of expectations, and EPS of USD 4.54 per ADR beat the USD 4.43 consensus by 2.7% and rose 69% year on year, in line with net income. This is the third consecutive quarter of beat-and-raise, and it came with an upgrade to the multi-year AI outlook, with agentic AI named as an additional growth engine on top of the cloud AI build-out.</a:t>
             </a:r>
             <a:endParaRPr lang="en-US" sz="870" dirty="0"/>
           </a:p>
@@ -3367,7 +3367,7 @@
                 <a:ea typeface="Nunito" pitchFamily="34" charset="-122"/>
                 <a:cs typeface="Nunito" pitchFamily="34" charset="-120"/>
               </a:rPr>
-              <a:t>ADR in USD, weekly, April 2005 to 15 October 2026 · Bloomberg 12m-forward consensus EPS in TWD per ADR · 40-week simple moving average · Log scale · Last price is the 15 October (results day) print</a:t>
+              <a:t>ADR in USD, weekly, January 2010 to 15 October 2026 · Bloomberg 12m-forward consensus EPS per ADR in USD, at Bloomberg’s implied exchange rate · 40-week simple moving average · Log scale · Last price is the 15 October (results day) print</a:t>
             </a:r>
             <a:endParaRPr lang="en-US" sz="720" dirty="0"/>
           </a:p>
@@ -3433,7 +3433,7 @@
                 <a:ea typeface="Nunito" pitchFamily="34" charset="-122"/>
                 <a:cs typeface="Nunito" pitchFamily="34" charset="-120"/>
               </a:rPr>
-              <a:t>Over 12 months the ADR is up 46% to USD 411 while consensus 12-month forward EPS rose 99% to TWD 675 per ADR, so the forward price-to-earnings ratio (P/E) fell from 25.3x to 19.7x. That is 16% above the 17.0x average since 2005, but below the one-year average of 23.3x and the 33.9x peak of February 2021. The price is 13% below its 2 October record and 3% above its 40-week moving average of USD 397. Analysts put the stock at about 16x 2027 earnings; a 10% upgrade at an unchanged price takes the multiple to 17.9x, near its average.</a:t>
+              <a:t>Over 12 months the ADR is up 46% to USD 411 while consensus 12-month forward EPS rose 88% to USD 20.8 per ADR, so the forward price-to-earnings ratio (P/E) fell from 25.3x to 19.7x. That is 16% above the 16.9x average since 2010, but below the one-year average of 23.3x and the 33.9x peak of February 2021. The price is 13% below its 2 October record and 3% above its 40-week moving average of USD 397. Analysts put the stock at about 16x 2027 earnings; a 10% upgrade at an unchanged price takes the multiple to 17.9x, near its average.</a:t>
             </a:r>
             <a:endParaRPr lang="en-US" sz="870" dirty="0"/>
           </a:p>

</xml_diff>